<commit_message>
Fix real-world rendering issues found by the corpus comparison
- useBgFill shapes show the slide background (aligned to the slide)
- Theme style-matrix fills and lines resolve pictures against the theme
  part's relationships (picture backgrounds from bgRef were lost)
- Legacy OLE objects take their preview picture from the VML drawing
- Gradients without a stop list inherit the stops of the style fill
- Non-placeholder text on slides uses the presentation defaultTextStyle;
  the master otherStyle only applies to masters and layouts
- Webdings 'n' maps to a black circle
- Fixtures cover useBgFill and stop-less gradients

Co-Authored-By: Claude Opus 5.5 <noreply@anthropic.com>
Claude-Session: https://claude.ai/code/session_015A8MAHWzu7DP7mvmPJpYQv
</commit_message>
<xml_diff>
--- a/samples/features/objects.pptx
+++ b/samples/features/objects.pptx
@@ -7146,6 +7146,106 @@
           </a:p>
         </p:txBody>
       </p:sp>
+      <p:sp>
+        <p:nvSpPr>
+          <p:cNvPr id="3" name="red"/>
+          <p:cNvSpPr/>
+          <p:nvPr/>
+        </p:nvSpPr>
+        <p:spPr>
+          <a:xfrm>
+            <a:off x="952500" y="1905000"/>
+            <a:ext cx="3810000" cy="3810000"/>
+          </a:xfrm>
+          <a:prstGeom prst="rect">
+            <a:avLst/>
+          </a:prstGeom>
+          <a:solidFill>
+            <a:srgbClr val="FF0000"/>
+          </a:solidFill>
+        </p:spPr>
+        <p:style>
+          <a:lnRef idx="2">
+            <a:schemeClr val="accent1">
+              <a:shade val="50000"/>
+            </a:schemeClr>
+          </a:lnRef>
+          <a:fillRef idx="1">
+            <a:schemeClr val="accent1"/>
+          </a:fillRef>
+          <a:effectRef idx="0">
+            <a:schemeClr val="accent1"/>
+          </a:effectRef>
+          <a:fontRef idx="minor">
+            <a:schemeClr val="lt1"/>
+          </a:fontRef>
+        </p:style>
+      </p:sp>
+      <p:sp useBgFill="1">
+        <p:nvSpPr>
+          <p:cNvPr id="4" name="bgfill"/>
+          <p:cNvSpPr/>
+          <p:nvPr/>
+        </p:nvSpPr>
+        <p:spPr>
+          <a:xfrm>
+            <a:off x="1905000" y="2857500"/>
+            <a:ext cx="1905000" cy="1905000"/>
+          </a:xfrm>
+          <a:prstGeom prst="roundRect">
+            <a:avLst/>
+          </a:prstGeom>
+        </p:spPr>
+        <p:style>
+          <a:lnRef idx="2">
+            <a:schemeClr val="accent1">
+              <a:shade val="50000"/>
+            </a:schemeClr>
+          </a:lnRef>
+          <a:fillRef idx="1">
+            <a:schemeClr val="accent1"/>
+          </a:fillRef>
+          <a:effectRef idx="0">
+            <a:schemeClr val="accent1"/>
+          </a:effectRef>
+          <a:fontRef idx="minor">
+            <a:schemeClr val="lt1"/>
+          </a:fontRef>
+        </p:style>
+      </p:sp>
+      <p:sp>
+        <p:nvSpPr>
+          <p:cNvPr id="5" name="grad no stops"/>
+          <p:cNvSpPr/>
+          <p:nvPr/>
+        </p:nvSpPr>
+        <p:spPr>
+          <a:xfrm>
+            <a:off x="6667500" y="1905000"/>
+            <a:ext cx="3810000" cy="3810000"/>
+          </a:xfrm>
+          <a:prstGeom prst="rect">
+            <a:avLst/>
+          </a:prstGeom>
+          <a:gradFill rotWithShape="1">
+            <a:lin ang="0" scaled="0"/>
+          </a:gradFill>
+        </p:spPr>
+        <p:style>
+          <a:lnRef idx="0">
+            <a:schemeClr val="accent1"/>
+          </a:lnRef>
+          <a:fillRef idx="3">
+            <a:schemeClr val="accent2"/>
+          </a:fillRef>
+          <a:effectRef idx="0">
+            <a:schemeClr val="accent1"/>
+          </a:effectRef>
+          <a:fontRef idx="minor">
+            <a:schemeClr val="lt1"/>
+          </a:fontRef>
+        </p:style>
+      </p:sp>
     </p:spTree>
   </p:cSld>
   <p:clrMapOvr>

</xml_diff>

<commit_message>
Draw chart error bars; fix horizontal bar legend order
- Error bars for bar, line and scatter series: fixed value, percentage,
  standard deviation, standard error and custom values; plus/minus/both,
  end caps and line formatting
- Horizontal bar charts list a vertical legend bottom-up, a horizontal
  legend in series order
- Fixture charts carry error bars and are checked against LibreOffice

Co-Authored-By: Claude Opus 5.5 <noreply@anthropic.com>
Claude-Session: https://claude.ai/code/session_015A8MAHWzu7DP7mvmPJpYQv
</commit_message>
<xml_diff>
--- a/samples/features/objects.pptx
+++ b/samples/features/objects.pptx
@@ -166,6 +166,12 @@
               </c:strCache>
             </c:strRef>
           </c:tx>
+          <c:errBars>
+            <c:errBarType val="both"/>
+            <c:errValType val="fixedVal"/>
+            <c:noEndCap val="0"/>
+            <c:val val="0.5"/>
+          </c:errBars>
           <c:cat>
             <c:strRef>
               <c:f>Sheet1!$A$2:$A$5</c:f>
@@ -1457,6 +1463,20 @@
             <c:symbol val="circle"/>
             <c:size val="7"/>
           </c:marker>
+          <c:errBars>
+            <c:errDir val="y"/>
+            <c:errBarType val="plus"/>
+            <c:errValType val="percentage"/>
+            <c:noEndCap val="0"/>
+            <c:val val="20"/>
+            <c:spPr>
+              <a:ln w="12700">
+                <a:solidFill>
+                  <a:srgbClr val="C00000"/>
+                </a:solidFill>
+              </a:ln>
+            </c:spPr>
+          </c:errBars>
           <c:cat>
             <c:strRef>
               <c:f>Sheet1!$A$2:$A$5</c:f>

</xml_diff>